<commit_message>
Finalize high-margin B2B SaaS Business Model slide in slides.html and PPTX
</commit_message>
<xml_diff>
--- a/Smart_Campus_Bus_Tracking_System.pptx
+++ b/Smart_Campus_Bus_Tracking_System.pptx
@@ -4079,7 +4079,7 @@
                 </a:solidFill>
                 <a:latin typeface="Inter"/>
               </a:rPr>
-              <a:t>A scalable B2B SaaS and zero-hardware transit management model designed for universities and fleet operators.</a:t>
+              <a:t>A high-margin B2B SaaS transit management platform converting university fleets into recurring subscription revenue.</a:t>
             </a:r>
           </a:p>
         </p:txBody>
@@ -4207,7 +4207,7 @@
                 </a:solidFill>
                 <a:latin typeface="Inter"/>
               </a:rPr>
-              <a:t>Private &amp; Public Varsities: </a:t>
+              <a:t>150+ Universities: </a:t>
             </a:r>
             <a:r>
               <a:rPr sz="1000">
@@ -4216,7 +4216,7 @@
                 </a:solidFill>
                 <a:latin typeface="Inter"/>
               </a:rPr>
-              <a:t>BUBT, NSU, BRACU, UIU, DU campus networks.</a:t>
+              <a:t>Public &amp; Private campus networks (BUBT, NSU, BRAC, DU).</a:t>
             </a:r>
           </a:p>
           <a:p>
@@ -4241,7 +4241,7 @@
                 </a:solidFill>
                 <a:latin typeface="Inter"/>
               </a:rPr>
-              <a:t>Schools &amp; Colleges: </a:t>
+              <a:t>K-12 Schools: </a:t>
             </a:r>
             <a:r>
               <a:rPr sz="1000">
@@ -4250,7 +4250,7 @@
                 </a:solidFill>
                 <a:latin typeface="Inter"/>
               </a:rPr>
-              <a:t>Institutional transport &amp; student safety tracking.</a:t>
+              <a:t>Student safety &amp; parental live tracking subscriptions.</a:t>
             </a:r>
           </a:p>
           <a:p>
@@ -4275,7 +4275,7 @@
                 </a:solidFill>
                 <a:latin typeface="Inter"/>
               </a:rPr>
-              <a:t>Corporate Shuttles: </a:t>
+              <a:t>Corporate Fleets: </a:t>
             </a:r>
             <a:r>
               <a:rPr sz="1000">
@@ -4284,7 +4284,7 @@
                 </a:solidFill>
                 <a:latin typeface="Inter"/>
               </a:rPr>
-              <a:t>Employee daily office commute &amp; shift transport fleets.</a:t>
+              <a:t>IT &amp; industrial employee shift shuttle fleets.</a:t>
             </a:r>
           </a:p>
         </p:txBody>
@@ -4421,7 +4421,7 @@
                 </a:solidFill>
                 <a:latin typeface="Inter"/>
               </a:rPr>
-              <a:t>Operates entirely via driver smartphones with no GPS OBD box needed.</a:t>
+              <a:t>100% Smartphone GPS based — no GPS tracker box needed.</a:t>
             </a:r>
           </a:p>
           <a:p>
@@ -4455,7 +4455,7 @@
                 </a:solidFill>
                 <a:latin typeface="Inter"/>
               </a:rPr>
-              <a:t>Real-time location, ETA, and delay notices eliminate idle wait time.</a:t>
+              <a:t>Real-time ETA &amp; live delay alerts eliminate idle wait time.</a:t>
             </a:r>
           </a:p>
           <a:p>
@@ -4480,7 +4480,7 @@
                 </a:solidFill>
                 <a:latin typeface="Inter"/>
               </a:rPr>
-              <a:t>Fuel &amp; Fleet Savings: </a:t>
+              <a:t>20-30% Fleet Savings: </a:t>
             </a:r>
             <a:r>
               <a:rPr sz="1000">
@@ -4489,7 +4489,7 @@
                 </a:solidFill>
                 <a:latin typeface="Inter"/>
               </a:rPr>
-              <a:t>Optimized route planning yields 20-30% transit efficiency gain.</a:t>
+              <a:t>Route &amp; schedule analytics optimize fuel &amp; transit costs.</a:t>
             </a:r>
           </a:p>
         </p:txBody>
@@ -4626,7 +4626,7 @@
                 </a:solidFill>
                 <a:latin typeface="Inter"/>
               </a:rPr>
-              <a:t>$15 - $25/bus/month recurring fee for institution fleet management.</a:t>
+              <a:t>$15 - $25 (৳1,500 - ৳2,500) / bus / month recurring fee.</a:t>
             </a:r>
           </a:p>
           <a:p>
@@ -4660,7 +4660,7 @@
                 </a:solidFill>
                 <a:latin typeface="Inter"/>
               </a:rPr>
-              <a:t>Custom branded app portal deployment &amp; institutional setup fees.</a:t>
+              <a:t>৳50,000 custom campus setup &amp; branded portal license.</a:t>
             </a:r>
           </a:p>
           <a:p>
@@ -4694,7 +4694,7 @@
                 </a:solidFill>
                 <a:latin typeface="Inter"/>
               </a:rPr>
-              <a:t>Targeted student deals for local food courts, bookshops &amp; stationeries.</a:t>
+              <a:t>Targeted deals for local food courts, bookshops &amp; cafes.</a:t>
             </a:r>
           </a:p>
         </p:txBody>
@@ -4774,7 +4774,7 @@
                   <a:srgbClr val="1A202C"/>
                 </a:solidFill>
               </a:rPr>
-              <a:t>🚀 Scalability &amp; Edge</a:t>
+              <a:t>📈 Unit Economics</a:t>
             </a:r>
           </a:p>
         </p:txBody>
@@ -4822,7 +4822,7 @@
                 </a:solidFill>
                 <a:latin typeface="Inter"/>
               </a:rPr>
-              <a:t>Rapid Onboarding: </a:t>
+              <a:t>85%+ Gross Margin: </a:t>
             </a:r>
             <a:r>
               <a:rPr sz="1000">
@@ -4831,7 +4831,7 @@
                 </a:solidFill>
                 <a:latin typeface="Inter"/>
               </a:rPr>
-              <a:t>New buses and routes can be onboarded in under 10 minutes.</a:t>
+              <a:t>Zero map licensing fee (Leaflet/OSM) &amp; low server cost.</a:t>
             </a:r>
           </a:p>
           <a:p>
@@ -4856,7 +4856,7 @@
                 </a:solidFill>
                 <a:latin typeface="Inter"/>
               </a:rPr>
-              <a:t>Zero Map Licensing Fees: </a:t>
+              <a:t>Scalable ARR: </a:t>
             </a:r>
             <a:r>
               <a:rPr sz="1000">
@@ -4865,7 +4865,7 @@
                 </a:solidFill>
                 <a:latin typeface="Inter"/>
               </a:rPr>
-              <a:t>Built on open Leaflet + OSM, avoiding expensive Google Maps API costs.</a:t>
+              <a:t>10 Universities (~150 buses) = ৳36 Lakhs / Year recurring.</a:t>
             </a:r>
           </a:p>
           <a:p>
@@ -4890,7 +4890,7 @@
                 </a:solidFill>
                 <a:latin typeface="Inter"/>
               </a:rPr>
-              <a:t>Data-Driven Expansion: </a:t>
+              <a:t>Rapid Onboarding: </a:t>
             </a:r>
             <a:r>
               <a:rPr sz="1000">
@@ -4899,7 +4899,7 @@
                 </a:solidFill>
                 <a:latin typeface="Inter"/>
               </a:rPr>
-              <a:t>Rich transit demand logs enable schedule &amp; capacity optimization.</a:t>
+              <a:t>Full university campus fleet goes live in &lt; 10 minutes.</a:t>
             </a:r>
           </a:p>
         </p:txBody>

</xml_diff>